<commit_message>
System Design vi: sd-14-031 deck scopes the ticket flow to the CAS-style model
Co-Authored-By: Claude Sonnet 5.5 <noreply@anthropic.com>
Claude-Session: https://claude.ai/code/session_01WnjciXNJBLEd8jy3HrG49S
</commit_message>
<xml_diff>
--- a/system-design-101/vi/lessons/sd-14-031/slides/sd-14-031.pptx
+++ b/system-design-101/vi/lessons/sd-14-031/slides/sd-14-031.pptx
@@ -2011,7 +2011,7 @@
         <p:spPr>
           <a:xfrm>
             <a:off x="914400" y="4762500"/>
-            <a:ext cx="9334500" cy="1619250"/>
+            <a:ext cx="9620250" cy="1809750"/>
           </a:xfrm>
           <a:prstGeom prst="rect">
             <a:avLst/>
@@ -2030,7 +2030,7 @@
               <a:buNone/>
             </a:pPr>
             <a:r>
-              <a:rPr lang="en-US" sz="2850" dirty="0" spc="-4" kern="0">
+              <a:rPr lang="en-US" sz="2850" dirty="0" spc="-62" kern="0">
                 <a:solidFill>
                   <a:srgbClr val="D8D3C4"/>
                 </a:solidFill>
@@ -2038,7 +2038,73 @@
                 <a:ea typeface="Be Vietnam Pro" pitchFamily="34" charset="-122"/>
                 <a:cs typeface="Be Vietnam Pro" pitchFamily="34" charset="-120"/>
               </a:rPr>
-              <a:t>Đăng</a:t>
+              <a:t>Trong</a:t>
+            </a:r>
+            <a:r>
+              <a:rPr lang="en-US" sz="2850" dirty="0" spc="-2" kern="0">
+                <a:solidFill>
+                  <a:srgbClr val="D8D3C4"/>
+                </a:solidFill>
+                <a:latin typeface="Be Vietnam Pro" pitchFamily="34" charset="0"/>
+                <a:ea typeface="Be Vietnam Pro" pitchFamily="34" charset="-122"/>
+                <a:cs typeface="Be Vietnam Pro" pitchFamily="34" charset="-120"/>
+              </a:rPr>
+              <a:t> mô</a:t>
+            </a:r>
+            <a:r>
+              <a:rPr lang="en-US" sz="2850" dirty="0" spc="0" kern="0">
+                <a:solidFill>
+                  <a:srgbClr val="D8D3C4"/>
+                </a:solidFill>
+                <a:latin typeface="Be Vietnam Pro" pitchFamily="34" charset="0"/>
+                <a:ea typeface="Be Vietnam Pro" pitchFamily="34" charset="-122"/>
+                <a:cs typeface="Be Vietnam Pro" pitchFamily="34" charset="-120"/>
+              </a:rPr>
+              <a:t> hình kiểu</a:t>
+            </a:r>
+            <a:r>
+              <a:rPr lang="en-US" sz="2850" dirty="0" spc="-43" kern="0">
+                <a:solidFill>
+                  <a:srgbClr val="D8D3C4"/>
+                </a:solidFill>
+                <a:latin typeface="Be Vietnam Pro" pitchFamily="34" charset="0"/>
+                <a:ea typeface="Be Vietnam Pro" pitchFamily="34" charset="-122"/>
+                <a:cs typeface="Be Vietnam Pro" pitchFamily="34" charset="-120"/>
+              </a:rPr>
+              <a:t> CAS</a:t>
+            </a:r>
+            <a:r>
+              <a:rPr lang="en-US" sz="2850" dirty="0" spc="1" kern="0">
+                <a:solidFill>
+                  <a:srgbClr val="D8D3C4"/>
+                </a:solidFill>
+                <a:latin typeface="Be Vietnam Pro" pitchFamily="34" charset="0"/>
+                <a:ea typeface="Be Vietnam Pro" pitchFamily="34" charset="-122"/>
+                <a:cs typeface="Be Vietnam Pro" pitchFamily="34" charset="-120"/>
+              </a:rPr>
+              <a:t> của</a:t>
+            </a:r>
+            <a:r>
+              <a:rPr lang="en-US" sz="2850" dirty="0" spc="-2" kern="0">
+                <a:solidFill>
+                  <a:srgbClr val="D8D3C4"/>
+                </a:solidFill>
+                <a:latin typeface="Be Vietnam Pro" pitchFamily="34" charset="0"/>
+                <a:ea typeface="Be Vietnam Pro" pitchFamily="34" charset="-122"/>
+                <a:cs typeface="Be Vietnam Pro" pitchFamily="34" charset="-120"/>
+              </a:rPr>
+              <a:t> bài:</a:t>
+            </a:r>
+            <a:r>
+              <a:rPr lang="en-US" sz="2850" dirty="0" spc="10" kern="0">
+                <a:solidFill>
+                  <a:srgbClr val="D8D3C4"/>
+                </a:solidFill>
+                <a:latin typeface="Be Vietnam Pro" pitchFamily="34" charset="0"/>
+                <a:ea typeface="Be Vietnam Pro" pitchFamily="34" charset="-122"/>
+                <a:cs typeface="Be Vietnam Pro" pitchFamily="34" charset="-120"/>
+              </a:rPr>
+              <a:t> đăng</a:t>
             </a:r>
             <a:r>
               <a:rPr lang="en-US" sz="2850" dirty="0" spc="-1" kern="0">
@@ -2052,6 +2118,171 @@
               <a:t> nhập</a:t>
             </a:r>
             <a:r>
+              <a:rPr lang="en-US" sz="2850" dirty="0" spc="-10" kern="0">
+                <a:solidFill>
+                  <a:srgbClr val="D8D3C4"/>
+                </a:solidFill>
+                <a:latin typeface="Be Vietnam Pro" pitchFamily="34" charset="0"/>
+                <a:ea typeface="Be Vietnam Pro" pitchFamily="34" charset="-122"/>
+                <a:cs typeface="Be Vietnam Pro" pitchFamily="34" charset="-120"/>
+              </a:rPr>
+              <a:t> một</a:t>
+            </a:r>
+            <a:r>
+              <a:rPr lang="en-US" sz="2850" dirty="0" spc="1" kern="0">
+                <a:solidFill>
+                  <a:srgbClr val="D8D3C4"/>
+                </a:solidFill>
+                <a:latin typeface="Be Vietnam Pro" pitchFamily="34" charset="0"/>
+                <a:ea typeface="Be Vietnam Pro" pitchFamily="34" charset="-122"/>
+                <a:cs typeface="Be Vietnam Pro" pitchFamily="34" charset="-120"/>
+              </a:rPr>
+              <a:t> lần</a:t>
+            </a:r>
+            <a:r>
+              <a:rPr lang="en-US" sz="2850" dirty="0" spc="0" kern="0">
+                <a:solidFill>
+                  <a:srgbClr val="D8D3C4"/>
+                </a:solidFill>
+                <a:latin typeface="Be Vietnam Pro" pitchFamily="34" charset="0"/>
+                <a:ea typeface="Be Vietnam Pro" pitchFamily="34" charset="-122"/>
+                <a:cs typeface="Be Vietnam Pro" pitchFamily="34" charset="-120"/>
+              </a:rPr>
+              <a:t> ở</a:t>
+            </a:r>
+            <a:r>
+              <a:rPr lang="en-US" sz="2850" dirty="0" spc="-11" kern="0">
+                <a:solidFill>
+                  <a:srgbClr val="D8D3C4"/>
+                </a:solidFill>
+                <a:latin typeface="Be Vietnam Pro" pitchFamily="34" charset="0"/>
+                <a:ea typeface="Be Vietnam Pro" pitchFamily="34" charset="-122"/>
+                <a:cs typeface="Be Vietnam Pro" pitchFamily="34" charset="-120"/>
+              </a:rPr>
+              <a:t> máy</a:t>
+            </a:r>
+            <a:r>
+              <a:rPr lang="en-US" sz="2850" dirty="0" spc="-1" kern="0">
+                <a:solidFill>
+                  <a:srgbClr val="D8D3C4"/>
+                </a:solidFill>
+                <a:latin typeface="Be Vietnam Pro" pitchFamily="34" charset="0"/>
+                <a:ea typeface="Be Vietnam Pro" pitchFamily="34" charset="-122"/>
+                <a:cs typeface="Be Vietnam Pro" pitchFamily="34" charset="-120"/>
+              </a:rPr>
+              <a:t> chủ</a:t>
+            </a:r>
+            <a:r>
+              <a:rPr lang="en-US" sz="2850" dirty="0" spc="23" kern="0">
+                <a:solidFill>
+                  <a:srgbClr val="D8D3C4"/>
+                </a:solidFill>
+                <a:latin typeface="Be Vietnam Pro" pitchFamily="34" charset="0"/>
+                <a:ea typeface="Be Vietnam Pro" pitchFamily="34" charset="-122"/>
+                <a:cs typeface="Be Vietnam Pro" pitchFamily="34" charset="-120"/>
+              </a:rPr>
+              <a:t> định</a:t>
+            </a:r>
+            <a:r>
+              <a:rPr lang="en-US" sz="2850" dirty="0" spc="0" kern="0">
+                <a:solidFill>
+                  <a:srgbClr val="D8D3C4"/>
+                </a:solidFill>
+                <a:latin typeface="Be Vietnam Pro" pitchFamily="34" charset="0"/>
+                <a:ea typeface="Be Vietnam Pro" pitchFamily="34" charset="-122"/>
+                <a:cs typeface="Be Vietnam Pro" pitchFamily="34" charset="-120"/>
+              </a:rPr>
+              <a:t> danh,</a:t>
+            </a:r>
+            <a:r>
+              <a:rPr lang="en-US" sz="2850" dirty="0" spc="-26" kern="0">
+                <a:solidFill>
+                  <a:srgbClr val="D8D3C4"/>
+                </a:solidFill>
+                <a:latin typeface="Be Vietnam Pro" pitchFamily="34" charset="0"/>
+                <a:ea typeface="Be Vietnam Pro" pitchFamily="34" charset="-122"/>
+                <a:cs typeface="Be Vietnam Pro" pitchFamily="34" charset="-120"/>
+              </a:rPr>
+              <a:t> rồi</a:t>
+            </a:r>
+            <a:r>
+              <a:rPr lang="en-US" sz="2850" dirty="0" spc="-1" kern="0">
+                <a:solidFill>
+                  <a:srgbClr val="D8D3C4"/>
+                </a:solidFill>
+                <a:latin typeface="Be Vietnam Pro" pitchFamily="34" charset="0"/>
+                <a:ea typeface="Be Vietnam Pro" pitchFamily="34" charset="-122"/>
+                <a:cs typeface="Be Vietnam Pro" pitchFamily="34" charset="-120"/>
+              </a:rPr>
+              <a:t> mỗi</a:t>
+            </a:r>
+            <a:r>
+              <a:rPr lang="en-US" sz="2850" dirty="0" spc="27" kern="0">
+                <a:solidFill>
+                  <a:srgbClr val="D8D3C4"/>
+                </a:solidFill>
+                <a:latin typeface="Be Vietnam Pro" pitchFamily="34" charset="0"/>
+                <a:ea typeface="Be Vietnam Pro" pitchFamily="34" charset="-122"/>
+                <a:cs typeface="Be Vietnam Pro" pitchFamily="34" charset="-120"/>
+              </a:rPr>
+              <a:t> ứng</a:t>
+            </a:r>
+            <a:r>
+              <a:rPr lang="en-US" sz="2850" dirty="0" spc="-2" kern="0">
+                <a:solidFill>
+                  <a:srgbClr val="D8D3C4"/>
+                </a:solidFill>
+                <a:latin typeface="Be Vietnam Pro" pitchFamily="34" charset="0"/>
+                <a:ea typeface="Be Vietnam Pro" pitchFamily="34" charset="-122"/>
+                <a:cs typeface="Be Vietnam Pro" pitchFamily="34" charset="-120"/>
+              </a:rPr>
+              <a:t> dụng</a:t>
+            </a:r>
+            <a:r>
+              <a:rPr lang="en-US" sz="2850" dirty="0" spc="-1" kern="0">
+                <a:solidFill>
+                  <a:srgbClr val="D8D3C4"/>
+                </a:solidFill>
+                <a:latin typeface="Be Vietnam Pro" pitchFamily="34" charset="0"/>
+                <a:ea typeface="Be Vietnam Pro" pitchFamily="34" charset="-122"/>
+                <a:cs typeface="Be Vietnam Pro" pitchFamily="34" charset="-120"/>
+              </a:rPr>
+              <a:t> tự</a:t>
+            </a:r>
+            <a:r>
+              <a:rPr lang="en-US" sz="2850" dirty="0" spc="0" kern="0">
+                <a:solidFill>
+                  <a:srgbClr val="D8D3C4"/>
+                </a:solidFill>
+                <a:latin typeface="Be Vietnam Pro" pitchFamily="34" charset="0"/>
+                <a:ea typeface="Be Vietnam Pro" pitchFamily="34" charset="-122"/>
+                <a:cs typeface="Be Vietnam Pro" pitchFamily="34" charset="-120"/>
+              </a:rPr>
+              <a:t> lập phiên</a:t>
+            </a:r>
+            <a:r>
+              <a:rPr lang="en-US" sz="2850" dirty="0" spc="9" kern="0">
+                <a:solidFill>
+                  <a:srgbClr val="D8D3C4"/>
+                </a:solidFill>
+                <a:latin typeface="Be Vietnam Pro" pitchFamily="34" charset="0"/>
+                <a:ea typeface="Be Vietnam Pro" pitchFamily="34" charset="-122"/>
+                <a:cs typeface="Be Vietnam Pro" pitchFamily="34" charset="-120"/>
+              </a:rPr>
+              <a:t> riêng</a:t>
+            </a:r>
+            <a:r>
+              <a:rPr lang="en-US" sz="2850" dirty="0" spc="-1" kern="0">
+                <a:solidFill>
+                  <a:srgbClr val="D8D3C4"/>
+                </a:solidFill>
+                <a:latin typeface="Be Vietnam Pro" pitchFamily="34" charset="0"/>
+                <a:ea typeface="Be Vietnam Pro" pitchFamily="34" charset="-122"/>
+                <a:cs typeface="Be Vietnam Pro" pitchFamily="34" charset="-120"/>
+              </a:rPr>
+              <a:t> nhờ</a:t>
+            </a:r>
+            <a:r>
               <a:rPr lang="en-US" sz="2850" dirty="0" spc="-9" kern="0">
                 <a:solidFill>
                   <a:srgbClr val="D8D3C4"/>
@@ -2063,7 +2294,7 @@
               <a:t> một</a:t>
             </a:r>
             <a:r>
-              <a:rPr lang="en-US" sz="2850" dirty="0" spc="0" kern="0">
+              <a:rPr lang="en-US" sz="2850" dirty="0" spc="-16" kern="0">
                 <a:solidFill>
                   <a:srgbClr val="D8D3C4"/>
                 </a:solidFill>
@@ -2071,208 +2302,32 @@
                 <a:ea typeface="Be Vietnam Pro" pitchFamily="34" charset="-122"/>
                 <a:cs typeface="Be Vietnam Pro" pitchFamily="34" charset="-120"/>
               </a:rPr>
-              <a:t> lần</a:t>
+              <a:t> vé</a:t>
+            </a:r>
+            <a:r>
+              <a:rPr lang="en-US" sz="2850" dirty="0" spc="-3" kern="0">
+                <a:solidFill>
+                  <a:srgbClr val="D8D3C4"/>
+                </a:solidFill>
+                <a:latin typeface="Be Vietnam Pro" pitchFamily="34" charset="0"/>
+                <a:ea typeface="Be Vietnam Pro" pitchFamily="34" charset="-122"/>
+                <a:cs typeface="Be Vietnam Pro" pitchFamily="34" charset="-120"/>
+              </a:rPr>
+              <a:t> dùng</a:t>
+            </a:r>
+            <a:r>
+              <a:rPr lang="en-US" sz="2850" dirty="0" spc="-9" kern="0">
+                <a:solidFill>
+                  <a:srgbClr val="D8D3C4"/>
+                </a:solidFill>
+                <a:latin typeface="Be Vietnam Pro" pitchFamily="34" charset="0"/>
+                <a:ea typeface="Be Vietnam Pro" pitchFamily="34" charset="-122"/>
+                <a:cs typeface="Be Vietnam Pro" pitchFamily="34" charset="-120"/>
+              </a:rPr>
+              <a:t> một</a:t>
             </a:r>
             <a:r>
               <a:rPr lang="en-US" sz="2850" dirty="0" spc="1" kern="0">
-                <a:solidFill>
-                  <a:srgbClr val="D8D3C4"/>
-                </a:solidFill>
-                <a:latin typeface="Be Vietnam Pro" pitchFamily="34" charset="0"/>
-                <a:ea typeface="Be Vietnam Pro" pitchFamily="34" charset="-122"/>
-                <a:cs typeface="Be Vietnam Pro" pitchFamily="34" charset="-120"/>
-              </a:rPr>
-              <a:t> ở</a:t>
-            </a:r>
-            <a:r>
-              <a:rPr lang="en-US" sz="2850" dirty="0" spc="-11" kern="0">
-                <a:solidFill>
-                  <a:srgbClr val="D8D3C4"/>
-                </a:solidFill>
-                <a:latin typeface="Be Vietnam Pro" pitchFamily="34" charset="0"/>
-                <a:ea typeface="Be Vietnam Pro" pitchFamily="34" charset="-122"/>
-                <a:cs typeface="Be Vietnam Pro" pitchFamily="34" charset="-120"/>
-              </a:rPr>
-              <a:t> máy</a:t>
-            </a:r>
-            <a:r>
-              <a:rPr lang="en-US" sz="2850" dirty="0" spc="-1" kern="0">
-                <a:solidFill>
-                  <a:srgbClr val="D8D3C4"/>
-                </a:solidFill>
-                <a:latin typeface="Be Vietnam Pro" pitchFamily="34" charset="0"/>
-                <a:ea typeface="Be Vietnam Pro" pitchFamily="34" charset="-122"/>
-                <a:cs typeface="Be Vietnam Pro" pitchFamily="34" charset="-120"/>
-              </a:rPr>
-              <a:t> chủ</a:t>
-            </a:r>
-            <a:r>
-              <a:rPr lang="en-US" sz="2850" dirty="0" spc="23" kern="0">
-                <a:solidFill>
-                  <a:srgbClr val="D8D3C4"/>
-                </a:solidFill>
-                <a:latin typeface="Be Vietnam Pro" pitchFamily="34" charset="0"/>
-                <a:ea typeface="Be Vietnam Pro" pitchFamily="34" charset="-122"/>
-                <a:cs typeface="Be Vietnam Pro" pitchFamily="34" charset="-120"/>
-              </a:rPr>
-              <a:t> định</a:t>
-            </a:r>
-            <a:r>
-              <a:rPr lang="en-US" sz="2850" dirty="0" spc="0" kern="0">
-                <a:solidFill>
-                  <a:srgbClr val="D8D3C4"/>
-                </a:solidFill>
-                <a:latin typeface="Be Vietnam Pro" pitchFamily="34" charset="0"/>
-                <a:ea typeface="Be Vietnam Pro" pitchFamily="34" charset="-122"/>
-                <a:cs typeface="Be Vietnam Pro" pitchFamily="34" charset="-120"/>
-              </a:rPr>
-              <a:t> danh,</a:t>
-            </a:r>
-            <a:r>
-              <a:rPr lang="en-US" sz="2850" dirty="0" spc="-26" kern="0">
-                <a:solidFill>
-                  <a:srgbClr val="D8D3C4"/>
-                </a:solidFill>
-                <a:latin typeface="Be Vietnam Pro" pitchFamily="34" charset="0"/>
-                <a:ea typeface="Be Vietnam Pro" pitchFamily="34" charset="-122"/>
-                <a:cs typeface="Be Vietnam Pro" pitchFamily="34" charset="-120"/>
-              </a:rPr>
-              <a:t> rồi</a:t>
-            </a:r>
-            <a:r>
-              <a:rPr lang="en-US" sz="2850" dirty="0" spc="-1" kern="0">
-                <a:solidFill>
-                  <a:srgbClr val="D8D3C4"/>
-                </a:solidFill>
-                <a:latin typeface="Be Vietnam Pro" pitchFamily="34" charset="0"/>
-                <a:ea typeface="Be Vietnam Pro" pitchFamily="34" charset="-122"/>
-                <a:cs typeface="Be Vietnam Pro" pitchFamily="34" charset="-120"/>
-              </a:rPr>
-              <a:t> mỗi</a:t>
-            </a:r>
-            <a:r>
-              <a:rPr lang="en-US" sz="2850" dirty="0" spc="27" kern="0">
-                <a:solidFill>
-                  <a:srgbClr val="D8D3C4"/>
-                </a:solidFill>
-                <a:latin typeface="Be Vietnam Pro" pitchFamily="34" charset="0"/>
-                <a:ea typeface="Be Vietnam Pro" pitchFamily="34" charset="-122"/>
-                <a:cs typeface="Be Vietnam Pro" pitchFamily="34" charset="-120"/>
-              </a:rPr>
-              <a:t> ứng</a:t>
-            </a:r>
-            <a:r>
-              <a:rPr lang="en-US" sz="2850" dirty="0" spc="-2" kern="0">
-                <a:solidFill>
-                  <a:srgbClr val="D8D3C4"/>
-                </a:solidFill>
-                <a:latin typeface="Be Vietnam Pro" pitchFamily="34" charset="0"/>
-                <a:ea typeface="Be Vietnam Pro" pitchFamily="34" charset="-122"/>
-                <a:cs typeface="Be Vietnam Pro" pitchFamily="34" charset="-120"/>
-              </a:rPr>
-              <a:t> dụng</a:t>
-            </a:r>
-            <a:r>
-              <a:rPr lang="en-US" sz="2850" dirty="0" spc="-1" kern="0">
-                <a:solidFill>
-                  <a:srgbClr val="D8D3C4"/>
-                </a:solidFill>
-                <a:latin typeface="Be Vietnam Pro" pitchFamily="34" charset="0"/>
-                <a:ea typeface="Be Vietnam Pro" pitchFamily="34" charset="-122"/>
-                <a:cs typeface="Be Vietnam Pro" pitchFamily="34" charset="-120"/>
-              </a:rPr>
-              <a:t> tự</a:t>
-            </a:r>
-            <a:r>
-              <a:rPr lang="en-US" sz="2850" dirty="0" spc="0" kern="0">
-                <a:solidFill>
-                  <a:srgbClr val="D8D3C4"/>
-                </a:solidFill>
-                <a:latin typeface="Be Vietnam Pro" pitchFamily="34" charset="0"/>
-                <a:ea typeface="Be Vietnam Pro" pitchFamily="34" charset="-122"/>
-                <a:cs typeface="Be Vietnam Pro" pitchFamily="34" charset="-120"/>
-              </a:rPr>
-              <a:t> lập</a:t>
-            </a:r>
-            <a:r>
-              <a:rPr lang="en-US" sz="2850" dirty="0" spc="-1" kern="0">
-                <a:solidFill>
-                  <a:srgbClr val="D8D3C4"/>
-                </a:solidFill>
-                <a:latin typeface="Be Vietnam Pro" pitchFamily="34" charset="0"/>
-                <a:ea typeface="Be Vietnam Pro" pitchFamily="34" charset="-122"/>
-                <a:cs typeface="Be Vietnam Pro" pitchFamily="34" charset="-120"/>
-              </a:rPr>
-              <a:t> phiên</a:t>
-            </a:r>
-            <a:r>
-              <a:rPr lang="en-US" sz="2850" dirty="0" spc="10" kern="0">
-                <a:solidFill>
-                  <a:srgbClr val="D8D3C4"/>
-                </a:solidFill>
-                <a:latin typeface="Be Vietnam Pro" pitchFamily="34" charset="0"/>
-                <a:ea typeface="Be Vietnam Pro" pitchFamily="34" charset="-122"/>
-                <a:cs typeface="Be Vietnam Pro" pitchFamily="34" charset="-120"/>
-              </a:rPr>
-              <a:t> riêng</a:t>
-            </a:r>
-            <a:r>
-              <a:rPr lang="en-US" sz="2850" dirty="0" spc="-1" kern="0">
-                <a:solidFill>
-                  <a:srgbClr val="D8D3C4"/>
-                </a:solidFill>
-                <a:latin typeface="Be Vietnam Pro" pitchFamily="34" charset="0"/>
-                <a:ea typeface="Be Vietnam Pro" pitchFamily="34" charset="-122"/>
-                <a:cs typeface="Be Vietnam Pro" pitchFamily="34" charset="-120"/>
-              </a:rPr>
-              <a:t> nhờ</a:t>
-            </a:r>
-            <a:r>
-              <a:rPr lang="en-US" sz="2850" dirty="0" spc="-9" kern="0">
-                <a:solidFill>
-                  <a:srgbClr val="D8D3C4"/>
-                </a:solidFill>
-                <a:latin typeface="Be Vietnam Pro" pitchFamily="34" charset="0"/>
-                <a:ea typeface="Be Vietnam Pro" pitchFamily="34" charset="-122"/>
-                <a:cs typeface="Be Vietnam Pro" pitchFamily="34" charset="-120"/>
-              </a:rPr>
-              <a:t> một</a:t>
-            </a:r>
-            <a:r>
-              <a:rPr lang="en-US" sz="2850" dirty="0" spc="-17" kern="0">
-                <a:solidFill>
-                  <a:srgbClr val="D8D3C4"/>
-                </a:solidFill>
-                <a:latin typeface="Be Vietnam Pro" pitchFamily="34" charset="0"/>
-                <a:ea typeface="Be Vietnam Pro" pitchFamily="34" charset="-122"/>
-                <a:cs typeface="Be Vietnam Pro" pitchFamily="34" charset="-120"/>
-              </a:rPr>
-              <a:t> vé</a:t>
-            </a:r>
-            <a:r>
-              <a:rPr lang="en-US" sz="2850" dirty="0" spc="-2" kern="0">
-                <a:solidFill>
-                  <a:srgbClr val="D8D3C4"/>
-                </a:solidFill>
-                <a:latin typeface="Be Vietnam Pro" pitchFamily="34" charset="0"/>
-                <a:ea typeface="Be Vietnam Pro" pitchFamily="34" charset="-122"/>
-                <a:cs typeface="Be Vietnam Pro" pitchFamily="34" charset="-120"/>
-              </a:rPr>
-              <a:t> dùng</a:t>
-            </a:r>
-            <a:r>
-              <a:rPr lang="en-US" sz="2850" dirty="0" spc="-9" kern="0">
-                <a:solidFill>
-                  <a:srgbClr val="D8D3C4"/>
-                </a:solidFill>
-                <a:latin typeface="Be Vietnam Pro" pitchFamily="34" charset="0"/>
-                <a:ea typeface="Be Vietnam Pro" pitchFamily="34" charset="-122"/>
-                <a:cs typeface="Be Vietnam Pro" pitchFamily="34" charset="-120"/>
-              </a:rPr>
-              <a:t> một</a:t>
-            </a:r>
-            <a:r>
-              <a:rPr lang="en-US" sz="2850" dirty="0" spc="0" kern="0">
                 <a:solidFill>
                   <a:srgbClr val="D8D3C4"/>
                 </a:solidFill>
@@ -5771,6 +5826,39 @@
               </a:rPr>
               <a:t> TIÊU</a:t>
             </a:r>
+            <a:r>
+              <a:rPr lang="en-US" sz="1950" b="1" spc="298" kern="0" dirty="0">
+                <a:solidFill>
+                  <a:srgbClr val="1F3FD1"/>
+                </a:solidFill>
+                <a:latin typeface="Be Vietnam Pro" pitchFamily="34" charset="0"/>
+                <a:ea typeface="Be Vietnam Pro" pitchFamily="34" charset="-122"/>
+                <a:cs typeface="Be Vietnam Pro" pitchFamily="34" charset="-120"/>
+              </a:rPr>
+              <a:t> ·</a:t>
+            </a:r>
+            <a:r>
+              <a:rPr lang="en-US" sz="1950" b="1" spc="299" kern="0" dirty="0">
+                <a:solidFill>
+                  <a:srgbClr val="1F3FD1"/>
+                </a:solidFill>
+                <a:latin typeface="Be Vietnam Pro" pitchFamily="34" charset="0"/>
+                <a:ea typeface="Be Vietnam Pro" pitchFamily="34" charset="-122"/>
+                <a:cs typeface="Be Vietnam Pro" pitchFamily="34" charset="-120"/>
+              </a:rPr>
+              <a:t> KIỂU</a:t>
+            </a:r>
+            <a:r>
+              <a:rPr lang="en-US" sz="1950" b="1" spc="268" kern="0" dirty="0">
+                <a:solidFill>
+                  <a:srgbClr val="1F3FD1"/>
+                </a:solidFill>
+                <a:latin typeface="Be Vietnam Pro" pitchFamily="34" charset="0"/>
+                <a:ea typeface="Be Vietnam Pro" pitchFamily="34" charset="-122"/>
+                <a:cs typeface="Be Vietnam Pro" pitchFamily="34" charset="-120"/>
+              </a:rPr>
+              <a:t> CAS</a:t>
+            </a:r>
             <a:endParaRPr lang="en-US" sz="1950" dirty="0"/>
           </a:p>
         </p:txBody>
@@ -6783,6 +6871,50 @@
               <a:buNone/>
             </a:pPr>
             <a:r>
+              <a:rPr lang="en-US" sz="2550" dirty="0" spc="3" kern="0">
+                <a:solidFill>
+                  <a:srgbClr val="14161C"/>
+                </a:solidFill>
+                <a:latin typeface="Be Vietnam Pro" pitchFamily="34" charset="0"/>
+                <a:ea typeface="Be Vietnam Pro" pitchFamily="34" charset="-122"/>
+                <a:cs typeface="Be Vietnam Pro" pitchFamily="34" charset="-120"/>
+              </a:rPr>
+              <a:t>Ba</a:t>
+            </a:r>
+            <a:r>
+              <a:rPr lang="en-US" sz="2550" dirty="0" spc="1" kern="0">
+                <a:solidFill>
+                  <a:srgbClr val="14161C"/>
+                </a:solidFill>
+                <a:latin typeface="Be Vietnam Pro" pitchFamily="34" charset="0"/>
+                <a:ea typeface="Be Vietnam Pro" pitchFamily="34" charset="-122"/>
+                <a:cs typeface="Be Vietnam Pro" pitchFamily="34" charset="-120"/>
+              </a:rPr>
+              <a:t> thẻ</a:t>
+            </a:r>
+            <a:r>
+              <a:rPr lang="en-US" sz="2550" dirty="0" spc="-19" kern="0">
+                <a:solidFill>
+                  <a:srgbClr val="14161C"/>
+                </a:solidFill>
+                <a:latin typeface="Be Vietnam Pro" pitchFamily="34" charset="0"/>
+                <a:ea typeface="Be Vietnam Pro" pitchFamily="34" charset="-122"/>
+                <a:cs typeface="Be Vietnam Pro" pitchFamily="34" charset="-120"/>
+              </a:rPr>
+              <a:t> trên</a:t>
+            </a:r>
+            <a:r>
+              <a:rPr lang="en-US" sz="2550" dirty="0" spc="0" kern="0">
+                <a:solidFill>
+                  <a:srgbClr val="14161C"/>
+                </a:solidFill>
+                <a:latin typeface="Be Vietnam Pro" pitchFamily="34" charset="0"/>
+                <a:ea typeface="Be Vietnam Pro" pitchFamily="34" charset="-122"/>
+                <a:cs typeface="Be Vietnam Pro" pitchFamily="34" charset="-120"/>
+              </a:rPr>
+              <a:t> là mô hình</a:t>
+            </a:r>
+            <a:r>
               <a:rPr lang="en-US" sz="2550" dirty="0" spc="2" kern="0">
                 <a:solidFill>
                   <a:srgbClr val="14161C"/>
@@ -6791,7 +6923,40 @@
                 <a:ea typeface="Be Vietnam Pro" pitchFamily="34" charset="-122"/>
                 <a:cs typeface="Be Vietnam Pro" pitchFamily="34" charset="-120"/>
               </a:rPr>
-              <a:t>Bài</a:t>
+              <a:t> kiểu</a:t>
+            </a:r>
+            <a:r>
+              <a:rPr lang="en-US" sz="2550" dirty="0" spc="-39" kern="0">
+                <a:solidFill>
+                  <a:srgbClr val="14161C"/>
+                </a:solidFill>
+                <a:latin typeface="Be Vietnam Pro" pitchFamily="34" charset="0"/>
+                <a:ea typeface="Be Vietnam Pro" pitchFamily="34" charset="-122"/>
+                <a:cs typeface="Be Vietnam Pro" pitchFamily="34" charset="-120"/>
+              </a:rPr>
+              <a:t> CAS</a:t>
+            </a:r>
+            <a:r>
+              <a:rPr lang="en-US" sz="2550" dirty="0" spc="-2" kern="0">
+                <a:solidFill>
+                  <a:srgbClr val="14161C"/>
+                </a:solidFill>
+                <a:latin typeface="Be Vietnam Pro" pitchFamily="34" charset="0"/>
+                <a:ea typeface="Be Vietnam Pro" pitchFamily="34" charset="-122"/>
+                <a:cs typeface="Be Vietnam Pro" pitchFamily="34" charset="-120"/>
+              </a:rPr>
+              <a:t> của</a:t>
+            </a:r>
+            <a:r>
+              <a:rPr lang="en-US" sz="2550" dirty="0" spc="-3" kern="0">
+                <a:solidFill>
+                  <a:srgbClr val="14161C"/>
+                </a:solidFill>
+                <a:latin typeface="Be Vietnam Pro" pitchFamily="34" charset="0"/>
+                <a:ea typeface="Be Vietnam Pro" pitchFamily="34" charset="-122"/>
+                <a:cs typeface="Be Vietnam Pro" pitchFamily="34" charset="-120"/>
+              </a:rPr>
+              <a:t> bài,</a:t>
             </a:r>
             <a:r>
               <a:rPr lang="en-US" sz="2550" dirty="0" spc="1" kern="0">
@@ -6802,7 +6967,62 @@
                 <a:ea typeface="Be Vietnam Pro" pitchFamily="34" charset="-122"/>
                 <a:cs typeface="Be Vietnam Pro" pitchFamily="34" charset="-120"/>
               </a:rPr>
-              <a:t> chỉ</a:t>
+              <a:t> kiểm</a:t>
+            </a:r>
+            <a:r>
+              <a:rPr lang="en-US" sz="2550" dirty="0" spc="-2" kern="0">
+                <a:solidFill>
+                  <a:srgbClr val="14161C"/>
+                </a:solidFill>
+                <a:latin typeface="Be Vietnam Pro" pitchFamily="34" charset="0"/>
+                <a:ea typeface="Be Vietnam Pro" pitchFamily="34" charset="-122"/>
+                <a:cs typeface="Be Vietnam Pro" pitchFamily="34" charset="-120"/>
+              </a:rPr>
+              <a:t> bằng</a:t>
+            </a:r>
+            <a:r>
+              <a:rPr lang="en-US" sz="2550" dirty="0" spc="2" kern="0">
+                <a:solidFill>
+                  <a:srgbClr val="14161C"/>
+                </a:solidFill>
+                <a:latin typeface="Be Vietnam Pro" pitchFamily="34" charset="0"/>
+                <a:ea typeface="Be Vietnam Pro" pitchFamily="34" charset="-122"/>
+                <a:cs typeface="Be Vietnam Pro" pitchFamily="34" charset="-120"/>
+              </a:rPr>
+              <a:t> thí</a:t>
+            </a:r>
+            <a:r>
+              <a:rPr lang="en-US" sz="2550" dirty="0" spc="0" kern="0">
+                <a:solidFill>
+                  <a:srgbClr val="14161C"/>
+                </a:solidFill>
+                <a:latin typeface="Be Vietnam Pro" pitchFamily="34" charset="0"/>
+                <a:ea typeface="Be Vietnam Pro" pitchFamily="34" charset="-122"/>
+                <a:cs typeface="Be Vietnam Pro" pitchFamily="34" charset="-120"/>
+              </a:rPr>
+              <a:t> nghiệm nhỏ:</a:t>
+            </a:r>
+            <a:r>
+              <a:rPr lang="en-US" sz="2550" dirty="0" spc="-5" kern="0">
+                <a:solidFill>
+                  <a:srgbClr val="14161C"/>
+                </a:solidFill>
+                <a:latin typeface="Be Vietnam Pro" pitchFamily="34" charset="0"/>
+                <a:ea typeface="Be Vietnam Pro" pitchFamily="34" charset="-122"/>
+                <a:cs typeface="Be Vietnam Pro" pitchFamily="34" charset="-120"/>
+              </a:rPr>
+              <a:t> một</a:t>
+            </a:r>
+            <a:r>
+              <a:rPr lang="en-US" sz="2550" dirty="0" spc="-9" kern="0">
+                <a:solidFill>
+                  <a:srgbClr val="14161C"/>
+                </a:solidFill>
+                <a:latin typeface="Be Vietnam Pro" pitchFamily="34" charset="0"/>
+                <a:ea typeface="Be Vietnam Pro" pitchFamily="34" charset="-122"/>
+                <a:cs typeface="Be Vietnam Pro" pitchFamily="34" charset="-120"/>
+              </a:rPr>
+              <a:t> máy</a:t>
             </a:r>
             <a:r>
               <a:rPr lang="en-US" sz="2550" dirty="0" spc="-1" kern="0">
@@ -6813,7 +7033,29 @@
                 <a:ea typeface="Be Vietnam Pro" pitchFamily="34" charset="-122"/>
                 <a:cs typeface="Be Vietnam Pro" pitchFamily="34" charset="-120"/>
               </a:rPr>
-              <a:t> nói</a:t>
+              <a:t> chủ</a:t>
+            </a:r>
+            <a:r>
+              <a:rPr lang="en-US" sz="2550" dirty="0" spc="20" kern="0">
+                <a:solidFill>
+                  <a:srgbClr val="14161C"/>
+                </a:solidFill>
+                <a:latin typeface="Be Vietnam Pro" pitchFamily="34" charset="0"/>
+                <a:ea typeface="Be Vietnam Pro" pitchFamily="34" charset="-122"/>
+                <a:cs typeface="Be Vietnam Pro" pitchFamily="34" charset="-120"/>
+              </a:rPr>
+              <a:t> định</a:t>
+            </a:r>
+            <a:r>
+              <a:rPr lang="en-US" sz="2550" dirty="0" spc="-1" kern="0">
+                <a:solidFill>
+                  <a:srgbClr val="14161C"/>
+                </a:solidFill>
+                <a:latin typeface="Be Vietnam Pro" pitchFamily="34" charset="0"/>
+                <a:ea typeface="Be Vietnam Pro" pitchFamily="34" charset="-122"/>
+                <a:cs typeface="Be Vietnam Pro" pitchFamily="34" charset="-120"/>
+              </a:rPr>
+              <a:t> danh,</a:t>
             </a:r>
             <a:r>
               <a:rPr lang="en-US" sz="2550" dirty="0" spc="0" kern="0">
@@ -6824,117 +7066,7 @@
                 <a:ea typeface="Be Vietnam Pro" pitchFamily="34" charset="-122"/>
                 <a:cs typeface="Be Vietnam Pro" pitchFamily="34" charset="-120"/>
               </a:rPr>
-              <a:t> cơ chế,</a:t>
-            </a:r>
-            <a:r>
-              <a:rPr lang="en-US" sz="2550" dirty="0" spc="1" kern="0">
-                <a:solidFill>
-                  <a:srgbClr val="14161C"/>
-                </a:solidFill>
-                <a:latin typeface="Be Vietnam Pro" pitchFamily="34" charset="0"/>
-                <a:ea typeface="Be Vietnam Pro" pitchFamily="34" charset="-122"/>
-                <a:cs typeface="Be Vietnam Pro" pitchFamily="34" charset="-120"/>
-              </a:rPr>
-              <a:t> kiểm</a:t>
-            </a:r>
-            <a:r>
-              <a:rPr lang="en-US" sz="2550" dirty="0" spc="-2" kern="0">
-                <a:solidFill>
-                  <a:srgbClr val="14161C"/>
-                </a:solidFill>
-                <a:latin typeface="Be Vietnam Pro" pitchFamily="34" charset="0"/>
-                <a:ea typeface="Be Vietnam Pro" pitchFamily="34" charset="-122"/>
-                <a:cs typeface="Be Vietnam Pro" pitchFamily="34" charset="-120"/>
-              </a:rPr>
-              <a:t> bằng</a:t>
-            </a:r>
-            <a:r>
-              <a:rPr lang="en-US" sz="2550" dirty="0" spc="1" kern="0">
-                <a:solidFill>
-                  <a:srgbClr val="14161C"/>
-                </a:solidFill>
-                <a:latin typeface="Be Vietnam Pro" pitchFamily="34" charset="0"/>
-                <a:ea typeface="Be Vietnam Pro" pitchFamily="34" charset="-122"/>
-                <a:cs typeface="Be Vietnam Pro" pitchFamily="34" charset="-120"/>
-              </a:rPr>
-              <a:t> thí</a:t>
-            </a:r>
-            <a:r>
-              <a:rPr lang="en-US" sz="2550" dirty="0" spc="0" kern="0">
-                <a:solidFill>
-                  <a:srgbClr val="14161C"/>
-                </a:solidFill>
-                <a:latin typeface="Be Vietnam Pro" pitchFamily="34" charset="0"/>
-                <a:ea typeface="Be Vietnam Pro" pitchFamily="34" charset="-122"/>
-                <a:cs typeface="Be Vietnam Pro" pitchFamily="34" charset="-120"/>
-              </a:rPr>
-              <a:t> nghiệm</a:t>
-            </a:r>
-            <a:r>
-              <a:rPr lang="en-US" sz="2550" dirty="0" spc="1" kern="0">
-                <a:solidFill>
-                  <a:srgbClr val="14161C"/>
-                </a:solidFill>
-                <a:latin typeface="Be Vietnam Pro" pitchFamily="34" charset="0"/>
-                <a:ea typeface="Be Vietnam Pro" pitchFamily="34" charset="-122"/>
-                <a:cs typeface="Be Vietnam Pro" pitchFamily="34" charset="-120"/>
-              </a:rPr>
-              <a:t> nhỏ:</a:t>
-            </a:r>
-            <a:r>
-              <a:rPr lang="en-US" sz="2550" dirty="0" spc="-5" kern="0">
-                <a:solidFill>
-                  <a:srgbClr val="14161C"/>
-                </a:solidFill>
-                <a:latin typeface="Be Vietnam Pro" pitchFamily="34" charset="0"/>
-                <a:ea typeface="Be Vietnam Pro" pitchFamily="34" charset="-122"/>
-                <a:cs typeface="Be Vietnam Pro" pitchFamily="34" charset="-120"/>
-              </a:rPr>
-              <a:t> một</a:t>
-            </a:r>
-            <a:r>
-              <a:rPr lang="en-US" sz="2550" dirty="0" spc="-9" kern="0">
-                <a:solidFill>
-                  <a:srgbClr val="14161C"/>
-                </a:solidFill>
-                <a:latin typeface="Be Vietnam Pro" pitchFamily="34" charset="0"/>
-                <a:ea typeface="Be Vietnam Pro" pitchFamily="34" charset="-122"/>
-                <a:cs typeface="Be Vietnam Pro" pitchFamily="34" charset="-120"/>
-              </a:rPr>
-              <a:t> máy</a:t>
-            </a:r>
-            <a:r>
-              <a:rPr lang="en-US" sz="2550" dirty="0" spc="-2" kern="0">
-                <a:solidFill>
-                  <a:srgbClr val="14161C"/>
-                </a:solidFill>
-                <a:latin typeface="Be Vietnam Pro" pitchFamily="34" charset="0"/>
-                <a:ea typeface="Be Vietnam Pro" pitchFamily="34" charset="-122"/>
-                <a:cs typeface="Be Vietnam Pro" pitchFamily="34" charset="-120"/>
-              </a:rPr>
-              <a:t> chủ</a:t>
-            </a:r>
-            <a:r>
-              <a:rPr lang="en-US" sz="2550" dirty="0" spc="21" kern="0">
-                <a:solidFill>
-                  <a:srgbClr val="14161C"/>
-                </a:solidFill>
-                <a:latin typeface="Be Vietnam Pro" pitchFamily="34" charset="0"/>
-                <a:ea typeface="Be Vietnam Pro" pitchFamily="34" charset="-122"/>
-                <a:cs typeface="Be Vietnam Pro" pitchFamily="34" charset="-120"/>
-              </a:rPr>
-              <a:t> định</a:t>
-            </a:r>
-            <a:r>
-              <a:rPr lang="en-US" sz="2550" dirty="0" spc="-1" kern="0">
-                <a:solidFill>
-                  <a:srgbClr val="14161C"/>
-                </a:solidFill>
-                <a:latin typeface="Be Vietnam Pro" pitchFamily="34" charset="0"/>
-                <a:ea typeface="Be Vietnam Pro" pitchFamily="34" charset="-122"/>
-                <a:cs typeface="Be Vietnam Pro" pitchFamily="34" charset="-120"/>
-              </a:rPr>
-              <a:t> danh, hai</a:t>
+              <a:t> hai</a:t>
             </a:r>
             <a:r>
               <a:rPr lang="en-US" sz="2550" dirty="0" spc="24" kern="0">
@@ -7536,6 +7668,39 @@
               </a:rPr>
               <a:t> 4</a:t>
             </a:r>
+            <a:r>
+              <a:rPr lang="en-US" sz="1950" b="1" spc="296" kern="0" dirty="0">
+                <a:solidFill>
+                  <a:srgbClr val="7C93FF"/>
+                </a:solidFill>
+                <a:latin typeface="Be Vietnam Pro" pitchFamily="34" charset="0"/>
+                <a:ea typeface="Be Vietnam Pro" pitchFamily="34" charset="-122"/>
+                <a:cs typeface="Be Vietnam Pro" pitchFamily="34" charset="-120"/>
+              </a:rPr>
+              <a:t> ·</a:t>
+            </a:r>
+            <a:r>
+              <a:rPr lang="en-US" sz="1950" b="1" spc="299" kern="0" dirty="0">
+                <a:solidFill>
+                  <a:srgbClr val="7C93FF"/>
+                </a:solidFill>
+                <a:latin typeface="Be Vietnam Pro" pitchFamily="34" charset="0"/>
+                <a:ea typeface="Be Vietnam Pro" pitchFamily="34" charset="-122"/>
+                <a:cs typeface="Be Vietnam Pro" pitchFamily="34" charset="-120"/>
+              </a:rPr>
+              <a:t> KIỂU</a:t>
+            </a:r>
+            <a:r>
+              <a:rPr lang="en-US" sz="1950" b="1" spc="268" kern="0" dirty="0">
+                <a:solidFill>
+                  <a:srgbClr val="7C93FF"/>
+                </a:solidFill>
+                <a:latin typeface="Be Vietnam Pro" pitchFamily="34" charset="0"/>
+                <a:ea typeface="Be Vietnam Pro" pitchFamily="34" charset="-122"/>
+                <a:cs typeface="Be Vietnam Pro" pitchFamily="34" charset="-120"/>
+              </a:rPr>
+              <a:t> CAS</a:t>
+            </a:r>
             <a:endParaRPr lang="en-US" sz="1950" dirty="0"/>
           </a:p>
         </p:txBody>
@@ -9379,6 +9544,39 @@
               </a:rPr>
               <a:t> 4</a:t>
             </a:r>
+            <a:r>
+              <a:rPr lang="en-US" sz="1950" b="1" spc="296" kern="0" dirty="0">
+                <a:solidFill>
+                  <a:srgbClr val="1F3FD1"/>
+                </a:solidFill>
+                <a:latin typeface="Be Vietnam Pro" pitchFamily="34" charset="0"/>
+                <a:ea typeface="Be Vietnam Pro" pitchFamily="34" charset="-122"/>
+                <a:cs typeface="Be Vietnam Pro" pitchFamily="34" charset="-120"/>
+              </a:rPr>
+              <a:t> ·</a:t>
+            </a:r>
+            <a:r>
+              <a:rPr lang="en-US" sz="1950" b="1" spc="299" kern="0" dirty="0">
+                <a:solidFill>
+                  <a:srgbClr val="1F3FD1"/>
+                </a:solidFill>
+                <a:latin typeface="Be Vietnam Pro" pitchFamily="34" charset="0"/>
+                <a:ea typeface="Be Vietnam Pro" pitchFamily="34" charset="-122"/>
+                <a:cs typeface="Be Vietnam Pro" pitchFamily="34" charset="-120"/>
+              </a:rPr>
+              <a:t> KIỂU</a:t>
+            </a:r>
+            <a:r>
+              <a:rPr lang="en-US" sz="1950" b="1" spc="268" kern="0" dirty="0">
+                <a:solidFill>
+                  <a:srgbClr val="1F3FD1"/>
+                </a:solidFill>
+                <a:latin typeface="Be Vietnam Pro" pitchFamily="34" charset="0"/>
+                <a:ea typeface="Be Vietnam Pro" pitchFamily="34" charset="-122"/>
+                <a:cs typeface="Be Vietnam Pro" pitchFamily="34" charset="-120"/>
+              </a:rPr>
+              <a:t> CAS</a:t>
+            </a:r>
             <a:endParaRPr lang="en-US" sz="1950" dirty="0"/>
           </a:p>
         </p:txBody>
@@ -11417,6 +11615,39 @@
               <a:t> ·</a:t>
             </a:r>
             <a:r>
+              <a:rPr lang="en-US" sz="1950" b="1" spc="299" kern="0" dirty="0">
+                <a:solidFill>
+                  <a:srgbClr val="FFB454"/>
+                </a:solidFill>
+                <a:latin typeface="Be Vietnam Pro" pitchFamily="34" charset="0"/>
+                <a:ea typeface="Be Vietnam Pro" pitchFamily="34" charset="-122"/>
+                <a:cs typeface="Be Vietnam Pro" pitchFamily="34" charset="-120"/>
+              </a:rPr>
+              <a:t> KIỂU</a:t>
+            </a:r>
+            <a:r>
+              <a:rPr lang="en-US" sz="1950" b="1" spc="268" kern="0" dirty="0">
+                <a:solidFill>
+                  <a:srgbClr val="FFB454"/>
+                </a:solidFill>
+                <a:latin typeface="Be Vietnam Pro" pitchFamily="34" charset="0"/>
+                <a:ea typeface="Be Vietnam Pro" pitchFamily="34" charset="-122"/>
+                <a:cs typeface="Be Vietnam Pro" pitchFamily="34" charset="-120"/>
+              </a:rPr>
+              <a:t> CAS</a:t>
+            </a:r>
+            <a:r>
+              <a:rPr lang="en-US" sz="1950" b="1" spc="297" kern="0" dirty="0">
+                <a:solidFill>
+                  <a:srgbClr val="FFB454"/>
+                </a:solidFill>
+                <a:latin typeface="Be Vietnam Pro" pitchFamily="34" charset="0"/>
+                <a:ea typeface="Be Vietnam Pro" pitchFamily="34" charset="-122"/>
+                <a:cs typeface="Be Vietnam Pro" pitchFamily="34" charset="-120"/>
+              </a:rPr>
+              <a:t> ·</a:t>
+            </a:r>
+            <a:r>
               <a:rPr lang="en-US" sz="1950" b="1" spc="300" kern="0" dirty="0">
                 <a:solidFill>
                   <a:srgbClr val="FFB454"/>
@@ -13698,6 +13929,39 @@
                 <a:ea typeface="Be Vietnam Pro" pitchFamily="34" charset="-122"/>
                 <a:cs typeface="Be Vietnam Pro" pitchFamily="34" charset="-120"/>
               </a:rPr>
+              <a:t> KIỂU</a:t>
+            </a:r>
+            <a:r>
+              <a:rPr lang="en-US" sz="1950" b="1" spc="268" kern="0" dirty="0">
+                <a:solidFill>
+                  <a:srgbClr val="0F766E"/>
+                </a:solidFill>
+                <a:latin typeface="Be Vietnam Pro" pitchFamily="34" charset="0"/>
+                <a:ea typeface="Be Vietnam Pro" pitchFamily="34" charset="-122"/>
+                <a:cs typeface="Be Vietnam Pro" pitchFamily="34" charset="-120"/>
+              </a:rPr>
+              <a:t> CAS</a:t>
+            </a:r>
+            <a:r>
+              <a:rPr lang="en-US" sz="1950" b="1" spc="296" kern="0" dirty="0">
+                <a:solidFill>
+                  <a:srgbClr val="0F766E"/>
+                </a:solidFill>
+                <a:latin typeface="Be Vietnam Pro" pitchFamily="34" charset="0"/>
+                <a:ea typeface="Be Vietnam Pro" pitchFamily="34" charset="-122"/>
+                <a:cs typeface="Be Vietnam Pro" pitchFamily="34" charset="-120"/>
+              </a:rPr>
+              <a:t> ·</a:t>
+            </a:r>
+            <a:r>
+              <a:rPr lang="en-US" sz="1950" b="1" spc="300" kern="0" dirty="0">
+                <a:solidFill>
+                  <a:srgbClr val="0F766E"/>
+                </a:solidFill>
+                <a:latin typeface="Be Vietnam Pro" pitchFamily="34" charset="0"/>
+                <a:ea typeface="Be Vietnam Pro" pitchFamily="34" charset="-122"/>
+                <a:cs typeface="Be Vietnam Pro" pitchFamily="34" charset="-120"/>
+              </a:rPr>
               <a:t> VÉ</a:t>
             </a:r>
             <a:endParaRPr lang="en-US" sz="1950" dirty="0"/>
@@ -16156,6 +16420,39 @@
               </a:rPr>
               <a:t> NHỚ</a:t>
             </a:r>
+            <a:r>
+              <a:rPr lang="en-US" sz="1950" b="1" spc="297" kern="0" dirty="0">
+                <a:solidFill>
+                  <a:srgbClr val="FF6A4D"/>
+                </a:solidFill>
+                <a:latin typeface="Be Vietnam Pro" pitchFamily="34" charset="0"/>
+                <a:ea typeface="Be Vietnam Pro" pitchFamily="34" charset="-122"/>
+                <a:cs typeface="Be Vietnam Pro" pitchFamily="34" charset="-120"/>
+              </a:rPr>
+              <a:t> ·</a:t>
+            </a:r>
+            <a:r>
+              <a:rPr lang="en-US" sz="1950" b="1" spc="299" kern="0" dirty="0">
+                <a:solidFill>
+                  <a:srgbClr val="FF6A4D"/>
+                </a:solidFill>
+                <a:latin typeface="Be Vietnam Pro" pitchFamily="34" charset="0"/>
+                <a:ea typeface="Be Vietnam Pro" pitchFamily="34" charset="-122"/>
+                <a:cs typeface="Be Vietnam Pro" pitchFamily="34" charset="-120"/>
+              </a:rPr>
+              <a:t> KIỂU</a:t>
+            </a:r>
+            <a:r>
+              <a:rPr lang="en-US" sz="1950" b="1" spc="268" kern="0" dirty="0">
+                <a:solidFill>
+                  <a:srgbClr val="FF6A4D"/>
+                </a:solidFill>
+                <a:latin typeface="Be Vietnam Pro" pitchFamily="34" charset="0"/>
+                <a:ea typeface="Be Vietnam Pro" pitchFamily="34" charset="-122"/>
+                <a:cs typeface="Be Vietnam Pro" pitchFamily="34" charset="-120"/>
+              </a:rPr>
+              <a:t> CAS</a:t>
+            </a:r>
             <a:endParaRPr lang="en-US" sz="1950" dirty="0"/>
           </a:p>
         </p:txBody>
@@ -20602,7 +20899,145 @@
       </p:sp>
       <p:sp>
         <p:nvSpPr>
-          <p:cNvPr id="37" name="Shape 35"/>
+          <p:cNvPr id="37" name="Text 35"/>
+          <p:cNvSpPr/>
+          <p:nvPr/>
+        </p:nvSpPr>
+        <p:spPr>
+          <a:xfrm>
+            <a:off x="9734550" y="4476750"/>
+            <a:ext cx="7429500" cy="342900"/>
+          </a:xfrm>
+          <a:prstGeom prst="rect">
+            <a:avLst/>
+          </a:prstGeom>
+          <a:noFill/>
+          <a:ln/>
+        </p:spPr>
+        <p:txBody>
+          <a:bodyPr wrap="square" lIns="0" tIns="0" rIns="0" bIns="0" rtlCol="0" anchor="ctr"/>
+          <a:lstStyle/>
+          <a:p>
+            <a:pPr algn="l" indent="0" marL="0">
+              <a:buNone/>
+            </a:pPr>
+            <a:r>
+              <a:rPr lang="en-US" sz="1950" dirty="0" spc="2" kern="0">
+                <a:solidFill>
+                  <a:srgbClr val="6B6A66"/>
+                </a:solidFill>
+                <a:latin typeface="Be Vietnam Pro" pitchFamily="34" charset="0"/>
+                <a:ea typeface="Be Vietnam Pro" pitchFamily="34" charset="-122"/>
+                <a:cs typeface="Be Vietnam Pro" pitchFamily="34" charset="-120"/>
+              </a:rPr>
+              <a:t>Giao</a:t>
+            </a:r>
+            <a:r>
+              <a:rPr lang="en-US" sz="1950" dirty="0" spc="4" kern="0">
+                <a:solidFill>
+                  <a:srgbClr val="6B6A66"/>
+                </a:solidFill>
+                <a:latin typeface="Be Vietnam Pro" pitchFamily="34" charset="0"/>
+                <a:ea typeface="Be Vietnam Pro" pitchFamily="34" charset="-122"/>
+                <a:cs typeface="Be Vietnam Pro" pitchFamily="34" charset="-120"/>
+              </a:rPr>
+              <a:t> thức</a:t>
+            </a:r>
+            <a:r>
+              <a:rPr lang="en-US" sz="1950" dirty="0" spc="-2" kern="0">
+                <a:solidFill>
+                  <a:srgbClr val="6B6A66"/>
+                </a:solidFill>
+                <a:latin typeface="Be Vietnam Pro" pitchFamily="34" charset="0"/>
+                <a:ea typeface="Be Vietnam Pro" pitchFamily="34" charset="-122"/>
+                <a:cs typeface="Be Vietnam Pro" pitchFamily="34" charset="-120"/>
+              </a:rPr>
+              <a:t> khác</a:t>
+            </a:r>
+            <a:r>
+              <a:rPr lang="en-US" sz="1950" dirty="0" spc="-4" kern="0">
+                <a:solidFill>
+                  <a:srgbClr val="6B6A66"/>
+                </a:solidFill>
+                <a:latin typeface="Be Vietnam Pro" pitchFamily="34" charset="0"/>
+                <a:ea typeface="Be Vietnam Pro" pitchFamily="34" charset="-122"/>
+                <a:cs typeface="Be Vietnam Pro" pitchFamily="34" charset="-120"/>
+              </a:rPr>
+              <a:t> có</a:t>
+            </a:r>
+            <a:r>
+              <a:rPr lang="en-US" sz="1950" dirty="0" spc="-1" kern="0">
+                <a:solidFill>
+                  <a:srgbClr val="6B6A66"/>
+                </a:solidFill>
+                <a:latin typeface="Be Vietnam Pro" pitchFamily="34" charset="0"/>
+                <a:ea typeface="Be Vietnam Pro" pitchFamily="34" charset="-122"/>
+                <a:cs typeface="Be Vietnam Pro" pitchFamily="34" charset="-120"/>
+              </a:rPr>
+              <a:t> thể</a:t>
+            </a:r>
+            <a:r>
+              <a:rPr lang="en-US" sz="1950" dirty="0" spc="-21" kern="0">
+                <a:solidFill>
+                  <a:srgbClr val="6B6A66"/>
+                </a:solidFill>
+                <a:latin typeface="Be Vietnam Pro" pitchFamily="34" charset="0"/>
+                <a:ea typeface="Be Vietnam Pro" pitchFamily="34" charset="-122"/>
+                <a:cs typeface="Be Vietnam Pro" pitchFamily="34" charset="-120"/>
+              </a:rPr>
+              <a:t> trả</a:t>
+            </a:r>
+            <a:r>
+              <a:rPr lang="en-US" sz="1950" dirty="0" spc="-29" kern="0">
+                <a:solidFill>
+                  <a:srgbClr val="6B6A66"/>
+                </a:solidFill>
+                <a:latin typeface="Be Vietnam Pro" pitchFamily="34" charset="0"/>
+                <a:ea typeface="Be Vietnam Pro" pitchFamily="34" charset="-122"/>
+                <a:cs typeface="Be Vietnam Pro" pitchFamily="34" charset="-120"/>
+              </a:rPr>
+              <a:t> kết</a:t>
+            </a:r>
+            <a:r>
+              <a:rPr lang="en-US" sz="1950" dirty="0" spc="-1" kern="0">
+                <a:solidFill>
+                  <a:srgbClr val="6B6A66"/>
+                </a:solidFill>
+                <a:latin typeface="Be Vietnam Pro" pitchFamily="34" charset="0"/>
+                <a:ea typeface="Be Vietnam Pro" pitchFamily="34" charset="-122"/>
+                <a:cs typeface="Be Vietnam Pro" pitchFamily="34" charset="-120"/>
+              </a:rPr>
+              <a:t> quả theo</a:t>
+            </a:r>
+            <a:r>
+              <a:rPr lang="en-US" sz="1950" dirty="0" spc="1" kern="0">
+                <a:solidFill>
+                  <a:srgbClr val="6B6A66"/>
+                </a:solidFill>
+                <a:latin typeface="Be Vietnam Pro" pitchFamily="34" charset="0"/>
+                <a:ea typeface="Be Vietnam Pro" pitchFamily="34" charset="-122"/>
+                <a:cs typeface="Be Vietnam Pro" pitchFamily="34" charset="-120"/>
+              </a:rPr>
+              <a:t> luồng</a:t>
+            </a:r>
+            <a:r>
+              <a:rPr lang="en-US" sz="1950" dirty="0" spc="-3" kern="0">
+                <a:solidFill>
+                  <a:srgbClr val="6B6A66"/>
+                </a:solidFill>
+                <a:latin typeface="Be Vietnam Pro" pitchFamily="34" charset="0"/>
+                <a:ea typeface="Be Vietnam Pro" pitchFamily="34" charset="-122"/>
+                <a:cs typeface="Be Vietnam Pro" pitchFamily="34" charset="-120"/>
+              </a:rPr>
+              <a:t> khác</a:t>
+            </a:r>
+            <a:endParaRPr lang="en-US" sz="1950" dirty="0"/>
+          </a:p>
+        </p:txBody>
+      </p:sp>
+      <p:sp>
+        <p:nvSpPr>
+          <p:cNvPr id="38" name="Shape 36"/>
           <p:cNvSpPr/>
           <p:nvPr/>
         </p:nvSpPr>
@@ -20626,7 +21061,7 @@
       </p:sp>
       <p:pic>
         <p:nvPicPr>
-          <p:cNvPr id="38" name="Moda image moda-export-watermark-6c08285c-2b0c-47b7-8832-5195e2ea6fcd" descr="">    </p:cNvPr>
+          <p:cNvPr id="39" name="Moda image moda-export-watermark-6c08285c-2b0c-47b7-8832-5195e2ea6fcd" descr="">    </p:cNvPr>
           <p:cNvPicPr>
             <a:picLocks noChangeAspect="1"/>
           </p:cNvPicPr>

</xml_diff>